<commit_message>
Point the deck at the commit that actually contains its evidence
Slide 13 sent readers to the repository root at dbc0a33, but the evidence for
the executed model was created after that commit, so its link returned 404.
The reference now names f739982 and the tag submission-2026-10-20, and every
linked path on the slide resolves at that commit. The comparison range and a
stale blob link to 6ff91a0 move to the same commit.

One link's href pointed at a different file from the path it displayed
(Java_Test_Results_2026-10-19.txt shown as the V3 acceptance record); it now
points at Camunda_V3_Acceptance_2026-10-19.txt.

Slides 2 to 12 are pixel-identical before and after; only 1 and 13 change.
</commit_message>
<xml_diff>
--- a/submissions/AISD/AISD_Presentation_2026-10-19.pptx
+++ b/submissions/AISD/AISD_Presentation_2026-10-19.pptx
@@ -465,7 +465,7 @@
           <a:p/>
           <a:p>
             <a:r>
-              <a:t>Open the deck and name the two release tags on screen: the initial release is submission-2026-09-29 at f6fec99, and everything in this deck is read against the tree at dbc0a33.</a:t>
+              <a:t>Open the deck and name the two release tags on screen: the initial release is submission-2026-09-29 at f6fec99, and everything in this deck is read against the tree at f739982, tagged submission-2026-10-20.</a:t>
             </a:r>
           </a:p>
           <a:p>
@@ -753,7 +753,7 @@
           </a:p>
           <a:p>
             <a:r>
-              <a:t>Say that every path on this slide opens at commit dbc0a33, and that the two tags make the before-and-after checkable without trusting the slides.</a:t>
+              <a:t>Say that every path on this slide opens at commit f739982, and that the two tags make the before-and-after checkable without trusting the slides.</a:t>
             </a:r>
           </a:p>
           <a:p>
@@ -2705,7 +2705,7 @@
                 </a:solidFill>
                 <a:latin typeface="Arial"/>
               </a:rPr>
-              <a:t>Current tree      dbc0a33  ·  group 10  ·  draft for second-owner review</a:t>
+              <a:t>Current tree      f739982  ·  tagged submission-2026-10-20  ·  group 10  ·  draft for second-owner review</a:t>
             </a:r>
           </a:p>
         </p:txBody>
@@ -6621,7 +6621,7 @@
                 </a:solidFill>
                 <a:latin typeface="Arial"/>
               </a:rPr>
-              <a:t>Repository paths are relative to the root at dbc0a33; each is linked to the GitHub copy.</a:t>
+              <a:t>Repository paths are relative to the root at f739982; each is linked to the GitHub copy.</a:t>
             </a:r>
           </a:p>
         </p:txBody>
@@ -7727,7 +7727,7 @@
                 <a:latin typeface="Arial"/>
                 <a:hlinkClick r:id="rId13"/>
               </a:rPr>
-              <a:t>github.com/Estrella6066773/HW_AISD/compare/f6fec99...dbc0a33</a:t>
+              <a:t>github.com/Estrella6066773/HW_AISD/compare/f6fec99...f739982</a:t>
             </a:r>
           </a:p>
         </p:txBody>
@@ -7810,7 +7810,7 @@
                 </a:solidFill>
                 <a:latin typeface="Arial"/>
               </a:rPr>
-              <a:t>Initial release   submission-2026-09-29  =  f6fec99     ·     Second release tree  dbc0a33     ·     Group 10, AISD UFCEP6-0-3</a:t>
+              <a:t>Initial release   submission-2026-09-29  =  f6fec99     ·     Second release tree  f739982     ·     Group 10, AISD UFCEP6-0-3</a:t>
             </a:r>
           </a:p>
         </p:txBody>

</xml_diff>

<commit_message>
Point the pack at the release tag and drop the stale commit references
The presentation named a commit fifteen behind HEAD as the current tree, and
the README dated the tag 19 October and called everything after it
documentation only. Both were wrong once the second-release test plan landed.

Reader-facing documents now identify the revised release by tag and say how to
resolve it, so the identifier cannot go stale again. The backlog no longer
claims the readable exports are unproduced, and PB-31 separates finished work
from an unrecorded sign-off instead of reading as fully accepted.

The contribution record and the tag status in the task list were still
described as empty and unsettled; they are not.
</commit_message>
<xml_diff>
--- a/submissions/AISD/AISD_Presentation_2026-10-19.pptx
+++ b/submissions/AISD/AISD_Presentation_2026-10-19.pptx
@@ -465,7 +465,7 @@
           <a:p/>
           <a:p>
             <a:r>
-              <a:t>Open the deck and name the two release tags on screen: the initial release is submission-2026-09-29 at f6fec99, and everything in this deck is read against the tree at f739982, tagged submission-2026-10-20.</a:t>
+              <a:t>Open the deck and name the two release tags on screen: the initial release is submission-2026-09-29 at f6fec99, and everything in this deck is read against the revised release, tagged submission-2026-10-20 (resolve it with git rev-parse submission-2026-10-20^{commit}).</a:t>
             </a:r>
           </a:p>
           <a:p>
@@ -753,7 +753,7 @@
           </a:p>
           <a:p>
             <a:r>
-              <a:t>Say that every path on this slide opens at commit f739982, and that the two tags make the before-and-after checkable without trusting the slides.</a:t>
+              <a:t>Say that every path on this slide opens at the revised release, tagged submission-2026-10-20, and that the two tags make the before-and-after checkable without trusting the slides.</a:t>
             </a:r>
           </a:p>
           <a:p>
@@ -2705,7 +2705,7 @@
                 </a:solidFill>
                 <a:latin typeface="Arial"/>
               </a:rPr>
-              <a:t>Current tree      f739982  ·  tagged submission-2026-10-20  ·  group 10  ·  reviewed by Ruby 2026-10-19</a:t>
+              <a:t>Revised release   submission-2026-10-20  ·  resolve: git rev-parse submission-2026-10-20^{commit}  ·  group 10  ·  reviewed by Ruby 2026-10-19</a:t>
             </a:r>
           </a:p>
         </p:txBody>
@@ -6621,7 +6621,7 @@
                 </a:solidFill>
                 <a:latin typeface="Arial"/>
               </a:rPr>
-              <a:t>Repository paths are relative to the root at f739982; each is linked to the GitHub copy.</a:t>
+              <a:t>Paths are relative to the root of submission-2026-10-20 (git rev-parse submission-2026-10-20^{commit}); each is linked to the GitHub copy.</a:t>
             </a:r>
           </a:p>
         </p:txBody>
@@ -7727,7 +7727,7 @@
                 <a:latin typeface="Arial"/>
                 <a:hlinkClick r:id="rId13"/>
               </a:rPr>
-              <a:t>github.com/Estrella6066773/HW_AISD/compare/f6fec99...f739982</a:t>
+              <a:t>github.com/Estrella6066773/HW_AISD/compare/f6fec99...submission-2026-10-20</a:t>
             </a:r>
           </a:p>
         </p:txBody>
@@ -7810,7 +7810,7 @@
                 </a:solidFill>
                 <a:latin typeface="Arial"/>
               </a:rPr>
-              <a:t>Initial release   submission-2026-09-29  =  f6fec99     ·     Second release tree  f739982     ·     Group 10, AISD UFCEP6-0-3</a:t>
+              <a:t>Initial release   submission-2026-09-29  =  f6fec99     ·     Revised release  submission-2026-10-20     ·     Group 10, AISD UFCEP6-0-3</a:t>
             </a:r>
           </a:p>
         </p:txBody>

</xml_diff>